<commit_message>
Refine story positioning to trust-led de-risked category discovery across deck and portal
</commit_message>
<xml_diff>
--- a/NL_Zepto_Growth_PM_Graduation_Project.pptx
+++ b/NL_Zepto_Growth_PM_Graduation_Project.pptx
@@ -3191,7 +3191,7 @@
               </a:defRPr>
             </a:pPr>
             <a:r>
-              <a:t>  QUICK COMMERCE GOT FASTER. CATEGORY CHOICE GOT HARDER.</a:t>
+              <a:t>  AI-POWERED TRUST-LED DISCOVERY FOR CROSS-CATEGORY GROWTH</a:t>
             </a:r>
           </a:p>
         </p:txBody>
@@ -3229,7 +3229,7 @@
               </a:defRPr>
             </a:pPr>
             <a:r>
-              <a:t>1. Users Repeat Grocery Routine Orders in Sub-45s Checkouts Without Exploring High-Margin Categories</a:t>
+              <a:t>1. Context &amp; Business Goal: Converting Daily Grocery Habits into Low-Risk Non-Grocery Trial</a:t>
             </a:r>
           </a:p>
           <a:p>
@@ -3241,7 +3241,7 @@
               </a:defRPr>
             </a:pPr>
             <a:r>
-              <a:t>High delivery speed drives daily staple retention, but routine habit loops create category tunnel vision.</a:t>
+              <a:t>The barrier is not lack of demand for new categories; it is low-trust, low-risk trial inside a grocery-first habit.</a:t>
             </a:r>
           </a:p>
         </p:txBody>
@@ -3298,7 +3298,7 @@
               </a:defRPr>
             </a:pPr>
             <a:r>
-              <a:t>📋 STRATEGIC BRIEF &amp; PROBLEM CORE</a:t>
+              <a:t>📋 STRATEGIC BRIEF &amp; PM SCOPE</a:t>
             </a:r>
           </a:p>
           <a:p>
@@ -3313,7 +3313,7 @@
               </a:defRPr>
             </a:pPr>
             <a:r>
-              <a:t>•  Routine Tunnel Vision: 71.2% review-mention share of grocery staples in synthetic corpus shows heavy grocery discussion dominance [Synthetic Corpus, 2,000 items].</a:t>
+              <a:t>•  Role &amp; Scope: PM on Zepto Growth Team driving trust-led cross-category discovery.</a:t>
             </a:r>
           </a:p>
           <a:p>
@@ -3328,7 +3328,7 @@
               </a:defRPr>
             </a:pPr>
             <a:r>
-              <a:t>•  The Margin Disconnect: Daily staples yield ~10% gross margin vs 35%–50% for Beauty &amp; Pet Care [Illustrative Assumption].</a:t>
+              <a:t>•  Observed Behavior: 71.2% review-mention share of grocery staples shows heavy discussion dominance [Synthetic Corpus, 2,000 items].</a:t>
             </a:r>
           </a:p>
           <a:p>
@@ -3445,7 +3445,7 @@
               </a:defRPr>
             </a:pPr>
             <a:r>
-              <a:t>•  Grocery Focus: High order frequency in daily staples, but non-grocery trial drops to &lt;8.2% of MAC.</a:t>
+              <a:t>•  Routine Habit Loop: Grocery refillers checkout in &lt;45s without exploring adjacent categories.</a:t>
             </a:r>
           </a:p>
           <a:p>
@@ -3475,7 +3475,7 @@
               </a:defRPr>
             </a:pPr>
             <a:r>
-              <a:t>•  Growth PM Scope: Design risk-free trial mechanisms to drive multi-category exploration without lowering checkout speed.</a:t>
+              <a:t>•  Growth PM Approach: Trigger de-risked trial during recurring grocery orders without interrupting 45s checkout speed.</a:t>
             </a:r>
           </a:p>
         </p:txBody>
@@ -3544,7 +3544,7 @@
               </a:defRPr>
             </a:pPr>
             <a:r>
-              <a:t>Live Streamlit App: https://zeptomvp.streamlit.app | Public Dataset &amp; Source Code: NL_Zepto_Growth_PM_Graduation_Project</a:t>
+              <a:t>Live Streamlit App: https://zeptomvp.streamlit.app | Public Source Code: NL_Zepto_Growth_PM_Graduation_Project</a:t>
             </a:r>
           </a:p>
         </p:txBody>
@@ -5211,7 +5211,7 @@
               </a:defRPr>
             </a:pPr>
             <a:r>
-              <a:t>  AD BANNERS SPAM CHECKOUTS. USERS ABANDON NEW CATEGORIES OVER HIDDEN RISK.</a:t>
+              <a:t>  FAST EMERGENCY UTILITY VS TRUSTED PLANNED DESTINATION</a:t>
             </a:r>
           </a:p>
         </p:txBody>
@@ -5249,7 +5249,7 @@
               </a:defRPr>
             </a:pPr>
             <a:r>
-              <a:t>2. Platforms Optimized 10-Minute Logistics Speed but Ignored Risk-Free Product Trial</a:t>
+              <a:t>2. Frequent Grocery Users Buy Planned Non-Grocery Items Elsewhere Due to Lack of Trust &amp; Risk-Free Trial</a:t>
             </a:r>
           </a:p>
           <a:p>
@@ -5261,7 +5261,7 @@
               </a:defRPr>
             </a:pPr>
             <a:r>
-              <a:t>Ad banners fail because users abandon non-grocery discovery over invisible quality and return risks.</a:t>
+              <a:t>Frequent grocery users do not expand into non-grocery categories because QCommerce is perceived as a fast emergency utility.</a:t>
             </a:r>
           </a:p>
         </p:txBody>
@@ -5420,7 +5420,7 @@
               </a:defRPr>
             </a:pPr>
             <a:r>
-              <a:t>❌ WHAT NOBODY HAS SOLVED (THE BLIND SPOT)</a:t>
+              <a:t>❌ WHAT NOBODY HAS SOLVED (THE PURCHASING LEAKAGE)</a:t>
             </a:r>
           </a:p>
           <a:p>
@@ -5450,7 +5450,7 @@
               </a:defRPr>
             </a:pPr>
             <a:r>
-              <a:t>•  Trust in Quality: 20.1% of discovery reviews (134/667) fear heat degrades dark store inventory [Synthetic Corpus, 667 subset].</a:t>
+              <a:t>•  Quality &amp; Expiry Fear: 20.1% of discovery subset (134/667) fear heat degrades dark store inventory [Synthetic Corpus, 667 subset].</a:t>
             </a:r>
           </a:p>
           <a:p>
@@ -5465,7 +5465,7 @@
               </a:defRPr>
             </a:pPr>
             <a:r>
-              <a:t>•  Return &amp; Refund Anxiety: 17% of surveyed users (4/24) cite chatbot refund loops as top barrier [User Survey Q4, N=24].</a:t>
+              <a:t>•  Return &amp; Refund Anxiety: 17% of surveyed users (4/24) cite refund chatbot loops as top barrier [User Survey Q4, N=24].</a:t>
             </a:r>
           </a:p>
           <a:p>
@@ -6206,7 +6206,7 @@
               </a:defRPr>
             </a:pPr>
             <a:r>
-              <a:t>  THE PROBLEM ISN'T BANNER VISIBILITY. IT'S FINANCIAL &amp; QUALITY RISK BEFORE CHECKOUT.</a:t>
+              <a:t>  AI REVIEW WORKFLOW &amp; PRIMARY RESEARCH SYNTHESIS</a:t>
             </a:r>
           </a:p>
         </p:txBody>
@@ -6244,7 +6244,7 @@
               </a:defRPr>
             </a:pPr>
             <a:r>
-              <a:t>3. Users Abandon New Categories Over Hidden Quality &amp; Choice Risk, Not Lack of Awareness</a:t>
+              <a:t>3. AI Review Pipeline Identified Recurring Barriers, Then Primary Research Validated 3 Core Blocker Buckets</a:t>
             </a:r>
           </a:p>
           <a:p>
@@ -6256,7 +6256,7 @@
               </a:defRPr>
             </a:pPr>
             <a:r>
-              <a:t>Synthesis of synthetic complaint patterns and primary survey responses isolates core purchase blockers.</a:t>
+              <a:t>Synthesizing synthetic review patterns and primary survey responses into 3 actionable barrier buckets.</a:t>
             </a:r>
           </a:p>
         </p:txBody>
@@ -6313,7 +6313,7 @@
               </a:defRPr>
             </a:pPr>
             <a:r>
-              <a:t>📊 SYNTHETIC REVIEW CORPUS ANALYSIS (2,000 ITEMS)</a:t>
+              <a:t>📊 AI REVIEW PIPELINE &amp; SYNTHETIC CORPUS (2,000 ITEMS)</a:t>
             </a:r>
           </a:p>
           <a:p>
@@ -6328,7 +6328,7 @@
               </a:defRPr>
             </a:pPr>
             <a:r>
-              <a:t>•  Corpus Framing: 2,000 synthetic complaint patterns (200 items x 10 source channels modeling real complaint types).</a:t>
+              <a:t>•  AI Pipeline: Ingested 2,000 synthetic items (200 x 10 channels) -&gt; Cleaned -&gt; Clustered complaint patterns.</a:t>
             </a:r>
           </a:p>
           <a:p>
@@ -6343,7 +6343,7 @@
               </a:defRPr>
             </a:pPr>
             <a:r>
-              <a:t>•  Operational Filter: Excluded 1,333 operational/delivery complaints (66.7%). Of the 667 discovery-relevant subset:</a:t>
+              <a:t>•  Operational Exclusion: Filtered 1,333 operational complaints (66.7%). Evaluated 667 discovery-relevant subset.</a:t>
             </a:r>
           </a:p>
           <a:p>
@@ -6358,7 +6358,64 @@
               </a:defRPr>
             </a:pPr>
             <a:r>
-              <a:t>•  • Trust in Quality (dark store expiry fear): 20.1% (134/667)</a:t>
+              <a:t>•  Barrier Distribution (667 subset): Quality Fear 20.1% (134/667), Impulse Fatigue 20.1% (134/667), Low Awareness 19.9% (133/667), Planned Mismatch 19.9% (133/667), Packaging Guilt 19.9% (133/667).</a:t>
+            </a:r>
+          </a:p>
+        </p:txBody>
+      </p:sp>
+      <p:sp>
+        <p:nvSpPr>
+          <p:cNvPr id="6" name="Rounded Rectangle 5"/>
+          <p:cNvSpPr/>
+          <p:nvPr/>
+        </p:nvSpPr>
+        <p:spPr>
+          <a:xfrm>
+            <a:off x="6291072" y="1755648"/>
+            <a:ext cx="5440680" cy="3474720"/>
+          </a:xfrm>
+          <a:prstGeom prst="roundRect">
+            <a:avLst/>
+          </a:prstGeom>
+          <a:solidFill>
+            <a:srgbClr val="1E1430"/>
+          </a:solidFill>
+          <a:ln w="19050">
+            <a:solidFill>
+              <a:srgbClr val="8224E3"/>
+            </a:solidFill>
+          </a:ln>
+        </p:spPr>
+        <p:style>
+          <a:lnRef idx="1">
+            <a:schemeClr val="accent1"/>
+          </a:lnRef>
+          <a:fillRef idx="3">
+            <a:schemeClr val="accent1"/>
+          </a:fillRef>
+          <a:effectRef idx="2">
+            <a:schemeClr val="accent1"/>
+          </a:effectRef>
+          <a:fontRef idx="minor">
+            <a:schemeClr val="lt1"/>
+          </a:fontRef>
+        </p:style>
+        <p:txBody>
+          <a:bodyPr rtlCol="0" anchor="ctr" wrap="square" lIns="164592" tIns="137160" rIns="164592" bIns="137160"/>
+          <a:lstStyle/>
+          <a:p>
+            <a:pPr algn="ctr">
+              <a:spcAft>
+                <a:spcPts val="600"/>
+              </a:spcAft>
+              <a:defRPr sz="1200" b="1">
+                <a:solidFill>
+                  <a:srgbClr val="FFD700"/>
+                </a:solidFill>
+              </a:defRPr>
+            </a:pPr>
+            <a:r>
+              <a:t>🎯 3 SYNTHESIZED BARRIER BUCKETS (USER SURVEY, N=24)</a:t>
             </a:r>
           </a:p>
           <a:p>
@@ -6373,7 +6430,7 @@
               </a:defRPr>
             </a:pPr>
             <a:r>
-              <a:t>•  • Checkout Impulse Fatigue (banner blindness): 20.1% (134/667)</a:t>
+              <a:t>•  1. Trust Barrier: Quality/expiry fear (25%, 6/24) &amp; Return/refund chatbot uncertainty (17%, 4/24) [Survey Q4].</a:t>
             </a:r>
           </a:p>
           <a:p>
@@ -6388,7 +6445,7 @@
               </a:defRPr>
             </a:pPr>
             <a:r>
-              <a:t>•  • Lack of Awareness (hidden submenus): 19.9% (133/667)</a:t>
+              <a:t>•  2. Purchase-Mode Barrier: Planned bulk-buy habit mismatch (33%, 8/24); 83% (20/24) buy planned items on Amazon/Nykaa/DMart.</a:t>
             </a:r>
           </a:p>
           <a:p>
@@ -6403,184 +6460,7 @@
               </a:defRPr>
             </a:pPr>
             <a:r>
-              <a:t>•  • Planned vs Emergency Mismatch (DMart bulk preference): 19.9% (133/667)</a:t>
-            </a:r>
-          </a:p>
-          <a:p>
-            <a:pPr>
-              <a:spcAft>
-                <a:spcPts val="400"/>
-              </a:spcAft>
-              <a:defRPr sz="950">
-                <a:solidFill>
-                  <a:srgbClr val="E2D9F3"/>
-                </a:solidFill>
-              </a:defRPr>
-            </a:pPr>
-            <a:r>
-              <a:t>•  • Ecological Packaging Guilt (single-item plastic waste): 19.9% (133/667)</a:t>
-            </a:r>
-          </a:p>
-        </p:txBody>
-      </p:sp>
-      <p:sp>
-        <p:nvSpPr>
-          <p:cNvPr id="6" name="Rounded Rectangle 5"/>
-          <p:cNvSpPr/>
-          <p:nvPr/>
-        </p:nvSpPr>
-        <p:spPr>
-          <a:xfrm>
-            <a:off x="6291072" y="1755648"/>
-            <a:ext cx="5440680" cy="3474720"/>
-          </a:xfrm>
-          <a:prstGeom prst="roundRect">
-            <a:avLst/>
-          </a:prstGeom>
-          <a:solidFill>
-            <a:srgbClr val="1E1430"/>
-          </a:solidFill>
-          <a:ln w="19050">
-            <a:solidFill>
-              <a:srgbClr val="8224E3"/>
-            </a:solidFill>
-          </a:ln>
-        </p:spPr>
-        <p:style>
-          <a:lnRef idx="1">
-            <a:schemeClr val="accent1"/>
-          </a:lnRef>
-          <a:fillRef idx="3">
-            <a:schemeClr val="accent1"/>
-          </a:fillRef>
-          <a:effectRef idx="2">
-            <a:schemeClr val="accent1"/>
-          </a:effectRef>
-          <a:fontRef idx="minor">
-            <a:schemeClr val="lt1"/>
-          </a:fontRef>
-        </p:style>
-        <p:txBody>
-          <a:bodyPr rtlCol="0" anchor="ctr" wrap="square" lIns="164592" tIns="137160" rIns="164592" bIns="137160"/>
-          <a:lstStyle/>
-          <a:p>
-            <a:pPr algn="ctr">
-              <a:spcAft>
-                <a:spcPts val="600"/>
-              </a:spcAft>
-              <a:defRPr sz="1200" b="1">
-                <a:solidFill>
-                  <a:srgbClr val="FFD700"/>
-                </a:solidFill>
-              </a:defRPr>
-            </a:pPr>
-            <a:r>
-              <a:t>🎯 PRIMARY USER SURVEY SCORECARD (N=24)</a:t>
-            </a:r>
-          </a:p>
-          <a:p>
-            <a:pPr>
-              <a:spcAft>
-                <a:spcPts val="400"/>
-              </a:spcAft>
-              <a:defRPr sz="950">
-                <a:solidFill>
-                  <a:srgbClr val="E2D9F3"/>
-                </a:solidFill>
-              </a:defRPr>
-            </a:pPr>
-            <a:r>
-              <a:t>•  79% Power Users (19/24 order weekly or more).</a:t>
-            </a:r>
-          </a:p>
-          <a:p>
-            <a:pPr>
-              <a:spcAft>
-                <a:spcPts val="400"/>
-              </a:spcAft>
-              <a:defRPr sz="950">
-                <a:solidFill>
-                  <a:srgbClr val="E2D9F3"/>
-                </a:solidFill>
-              </a:defRPr>
-            </a:pPr>
-            <a:r>
-              <a:t>•  83% Category Leakage (20/24 buy planned non-grocery on Amazon/Nykaa/DMart).</a:t>
-            </a:r>
-          </a:p>
-          <a:p>
-            <a:pPr>
-              <a:spcAft>
-                <a:spcPts val="400"/>
-              </a:spcAft>
-              <a:defRPr sz="950">
-                <a:solidFill>
-                  <a:srgbClr val="E2D9F3"/>
-                </a:solidFill>
-              </a:defRPr>
-            </a:pPr>
-            <a:r>
-              <a:t>•  Primary Non-Grocery Barriers (Q4):</a:t>
-            </a:r>
-          </a:p>
-          <a:p>
-            <a:pPr>
-              <a:spcAft>
-                <a:spcPts val="400"/>
-              </a:spcAft>
-              <a:defRPr sz="950">
-                <a:solidFill>
-                  <a:srgbClr val="E2D9F3"/>
-                </a:solidFill>
-              </a:defRPr>
-            </a:pPr>
-            <a:r>
-              <a:t>•  • Planned bulk-buy habit mismatch: 33% (8/24)</a:t>
-            </a:r>
-          </a:p>
-          <a:p>
-            <a:pPr>
-              <a:spcAft>
-                <a:spcPts val="400"/>
-              </a:spcAft>
-              <a:defRPr sz="950">
-                <a:solidFill>
-                  <a:srgbClr val="E2D9F3"/>
-                </a:solidFill>
-              </a:defRPr>
-            </a:pPr>
-            <a:r>
-              <a:t>•  • Dark-store quality &amp; expiry fear: 25% (6/24)</a:t>
-            </a:r>
-          </a:p>
-          <a:p>
-            <a:pPr>
-              <a:spcAft>
-                <a:spcPts val="400"/>
-              </a:spcAft>
-              <a:defRPr sz="950">
-                <a:solidFill>
-                  <a:srgbClr val="E2D9F3"/>
-                </a:solidFill>
-              </a:defRPr>
-            </a:pPr>
-            <a:r>
-              <a:t>•  • Low category awareness: 21% (5/24)</a:t>
-            </a:r>
-          </a:p>
-          <a:p>
-            <a:pPr>
-              <a:spcAft>
-                <a:spcPts val="400"/>
-              </a:spcAft>
-              <a:defRPr sz="950">
-                <a:solidFill>
-                  <a:srgbClr val="E2D9F3"/>
-                </a:solidFill>
-              </a:defRPr>
-            </a:pPr>
-            <a:r>
-              <a:t>•  • Return &amp; refund bot uncertainty: 17% (4/24) [Replaces unsourced 50% claim]</a:t>
+              <a:t>•  3. Salience Barrier: Low category awareness (21%, 5/24) due to search-centric speed and banner blindness.</a:t>
             </a:r>
           </a:p>
         </p:txBody>
@@ -6649,7 +6529,7 @@
               </a:defRPr>
             </a:pPr>
             <a:r>
-              <a:t>Users don't need intrusive checkout banner ads. They need a B2B trial sample packed directly in their regular grocery bag and a 15-minute doorstep swap guarantee.</a:t>
+              <a:t>Users don't need intrusive checkout banner ads. They need an AI trust cue, a B2B trial sample in their regular bag, and a 15-minute doorstep swap guarantee.</a:t>
             </a:r>
           </a:p>
         </p:txBody>
@@ -7306,7 +7186,7 @@
               </a:defRPr>
             </a:pPr>
             <a:r>
-              <a:t>  THEY USE ZEPTO EVERY MORNING. THEY JUST CAN'T TRUST NON-GROCERY ITEMS AT CHECKOUT.</a:t>
+              <a:t>  HIGH-FREQUENCY GROCERY BUYERS WHO LEAK NON-GROCERY SPEND</a:t>
             </a:r>
           </a:p>
         </p:txBody>
@@ -7344,7 +7224,7 @@
               </a:defRPr>
             </a:pPr>
             <a:r>
-              <a:t>4. Cautious Explorers Need Financial &amp; Quality Validation Before Buying Non-Grocery Items</a:t>
+              <a:t>4. Target Segment: High-Frequency Grocery Users Open to Low-Risk Adjacent Category Trials</a:t>
             </a:r>
           </a:p>
           <a:p>
@@ -7356,7 +7236,7 @@
               </a:defRPr>
             </a:pPr>
             <a:r>
-              <a:t>Behavioral mapping isolates power grocery buyers who hesitate on non-grocery trial.</a:t>
+              <a:t>Targeting retained grocery refuelers who already trust Zepto for daily essentials but buy non-groceries elsewhere.</a:t>
             </a:r>
           </a:p>
         </p:txBody>
@@ -7413,7 +7293,7 @@
               </a:defRPr>
             </a:pPr>
             <a:r>
-              <a:t>📊 BEHAVIORAL SEGMENTATION (2x2 MATRIX)</a:t>
+              <a:t>📊 TARGET COHORT PROFILE &amp; RATIONALE</a:t>
             </a:r>
           </a:p>
           <a:p>
@@ -7428,7 +7308,7 @@
               </a:defRPr>
             </a:pPr>
             <a:r>
-              <a:t>•  Habitual Refillers: Order daily staples in &lt;45s; ignore promotional homepage banners.</a:t>
+              <a:t>•  Cohort Definition: High-frequency grocery users (79% order weekly+, 19/24) who leak non-grocery spend to Amazon/Nykaa (83%, 20/24).</a:t>
             </a:r>
           </a:p>
           <a:p>
@@ -7443,7 +7323,7 @@
               </a:defRPr>
             </a:pPr>
             <a:r>
-              <a:t>•  Cautious Explorers: Want personal care and pet items but fear receiving near-expiry dark store inventory.</a:t>
+              <a:t>•  Strategic Fit: Retained users with high basket frequency; lower CAC than acquiring new users.</a:t>
             </a:r>
           </a:p>
           <a:p>
@@ -7458,22 +7338,7 @@
               </a:defRPr>
             </a:pPr>
             <a:r>
-              <a:t>•  Impulse Avoiders: Skip checkout recommendations to avoid hidden fees or extra packaging.</a:t>
-            </a:r>
-          </a:p>
-          <a:p>
-            <a:pPr>
-              <a:spcAft>
-                <a:spcPts val="400"/>
-              </a:spcAft>
-              <a:defRPr sz="950">
-                <a:solidFill>
-                  <a:srgbClr val="E2D9F3"/>
-                </a:solidFill>
-              </a:defRPr>
-            </a:pPr>
-            <a:r>
-              <a:t>•  Routine Questors: Convert when non-grocery buys cross-subsidize daily grocery savings.</a:t>
+              <a:t>•  Behavioral Obstacle: Code quick-commerce strictly as an urgent emergency utility, avoiding non-grocery items due to perceived quality risk.</a:t>
             </a:r>
           </a:p>
         </p:txBody>
@@ -9203,7 +9068,7 @@
               </a:defRPr>
             </a:pPr>
             <a:r>
-              <a:t>  THREE HORIZONS OF DISCOVERY - SAMPLE, SWAP, LOCK-IN.</a:t>
+              <a:t>  STRATEGIC ALTERNATIVES &amp; PRIORITIZATION MATRIX</a:t>
             </a:r>
           </a:p>
         </p:txBody>
@@ -9241,7 +9106,7 @@
               </a:defRPr>
             </a:pPr>
             <a:r>
-              <a:t>6. Horizon 1 Delivers Immediate 0-CAC Trial via Brand-Funded Grocery Bag Sampling</a:t>
+              <a:t>6. Strategic Comparison: Why Trust-Led In-Bag Sampling Beats Ad Banners &amp; Discounting</a:t>
             </a:r>
           </a:p>
           <a:p>
@@ -9253,7 +9118,7 @@
               </a:defRPr>
             </a:pPr>
             <a:r>
-              <a:t>RICE scoring prioritizes low-effort, brand-funded sampling over operational hardware changes.</a:t>
+              <a:t>Comparing alternative growth levers demonstrates why in-bag trial provides the highest impact at lowest effort.</a:t>
             </a:r>
           </a:p>
         </p:txBody>
@@ -9310,7 +9175,7 @@
               </a:defRPr>
             </a:pPr>
             <a:r>
-              <a:t>🏆 THREE STRATEGIC HORIZONS</a:t>
+              <a:t>⚡ ALTERNATIVES VS TRUST-LED SAMPLING</a:t>
             </a:r>
           </a:p>
           <a:p>
@@ -9325,7 +9190,7 @@
               </a:defRPr>
             </a:pPr>
             <a:r>
-              <a:t>•  Horizon 1 (MVP) — B2B Discovery Sampler &amp; Pass: Brand-funded trial samples placed inside regular grocery bags at Rs. 0 [0-CapEx / 0-CAC]. RICE Score: 210.0 [Illustrative Model Score].</a:t>
+              <a:t>•  Homepage Banners: Ignored due to impulse fatigue (20.1% review subset); zero impact on trust.</a:t>
             </a:r>
           </a:p>
           <a:p>
@@ -9340,7 +9205,7 @@
               </a:defRPr>
             </a:pPr>
             <a:r>
-              <a:t>•  Horizon 2 (Growth) — 15-Min Doorstep Swap &amp; Storage Audit: Reverse logistics rider replacement + dark store temperature/CCTV telemetry [Operational CapEx]. RICE Score: 180.0 [Illustrative Model Score].</a:t>
+              <a:t>•  Broad Discounting: Destroys unit margins without addressing quality/expiry fears.</a:t>
             </a:r>
           </a:p>
           <a:p>
@@ -9355,64 +9220,7 @@
               </a:defRPr>
             </a:pPr>
             <a:r>
-              <a:t>•  Horizon 3 (Vision) — Category Quest Loyalty Engine: Multi-category streak board unlocking grocery point multipliers [RICE Score: 160.0].</a:t>
-            </a:r>
-          </a:p>
-        </p:txBody>
-      </p:sp>
-      <p:sp>
-        <p:nvSpPr>
-          <p:cNvPr id="6" name="Rounded Rectangle 5"/>
-          <p:cNvSpPr/>
-          <p:nvPr/>
-        </p:nvSpPr>
-        <p:spPr>
-          <a:xfrm>
-            <a:off x="6291072" y="1755648"/>
-            <a:ext cx="5440680" cy="3474720"/>
-          </a:xfrm>
-          <a:prstGeom prst="roundRect">
-            <a:avLst/>
-          </a:prstGeom>
-          <a:solidFill>
-            <a:srgbClr val="1E1430"/>
-          </a:solidFill>
-          <a:ln w="19050">
-            <a:solidFill>
-              <a:srgbClr val="8224E3"/>
-            </a:solidFill>
-          </a:ln>
-        </p:spPr>
-        <p:style>
-          <a:lnRef idx="1">
-            <a:schemeClr val="accent1"/>
-          </a:lnRef>
-          <a:fillRef idx="3">
-            <a:schemeClr val="accent1"/>
-          </a:fillRef>
-          <a:effectRef idx="2">
-            <a:schemeClr val="accent1"/>
-          </a:effectRef>
-          <a:fontRef idx="minor">
-            <a:schemeClr val="lt1"/>
-          </a:fontRef>
-        </p:style>
-        <p:txBody>
-          <a:bodyPr rtlCol="0" anchor="ctr" wrap="square" lIns="164592" tIns="137160" rIns="164592" bIns="137160"/>
-          <a:lstStyle/>
-          <a:p>
-            <a:pPr algn="ctr">
-              <a:spcAft>
-                <a:spcPts val="600"/>
-              </a:spcAft>
-              <a:defRPr sz="1200" b="1">
-                <a:solidFill>
-                  <a:srgbClr val="FFD700"/>
-                </a:solidFill>
-              </a:defRPr>
-            </a:pPr>
-            <a:r>
-              <a:t>📋 HORIZON 1 (MVP) RICE METRICS BREAKDOWN</a:t>
+              <a:t>•  Ops Overhaul: Requires massive CapEx before validating customer demand.</a:t>
             </a:r>
           </a:p>
           <a:p>
@@ -9427,7 +9235,64 @@
               </a:defRPr>
             </a:pPr>
             <a:r>
-              <a:t>•  Reach: 9/10 — Touches every active grocery shopping cart on Zepto.</a:t>
+              <a:t>•  Trust-Led Sampling (MVP): 0-CapEx, 0-CAC trial delivered inside active grocery bags with grocery-linked rewards.</a:t>
+            </a:r>
+          </a:p>
+        </p:txBody>
+      </p:sp>
+      <p:sp>
+        <p:nvSpPr>
+          <p:cNvPr id="6" name="Rounded Rectangle 5"/>
+          <p:cNvSpPr/>
+          <p:nvPr/>
+        </p:nvSpPr>
+        <p:spPr>
+          <a:xfrm>
+            <a:off x="6291072" y="1755648"/>
+            <a:ext cx="5440680" cy="3474720"/>
+          </a:xfrm>
+          <a:prstGeom prst="roundRect">
+            <a:avLst/>
+          </a:prstGeom>
+          <a:solidFill>
+            <a:srgbClr val="1E1430"/>
+          </a:solidFill>
+          <a:ln w="19050">
+            <a:solidFill>
+              <a:srgbClr val="8224E3"/>
+            </a:solidFill>
+          </a:ln>
+        </p:spPr>
+        <p:style>
+          <a:lnRef idx="1">
+            <a:schemeClr val="accent1"/>
+          </a:lnRef>
+          <a:fillRef idx="3">
+            <a:schemeClr val="accent1"/>
+          </a:fillRef>
+          <a:effectRef idx="2">
+            <a:schemeClr val="accent1"/>
+          </a:effectRef>
+          <a:fontRef idx="minor">
+            <a:schemeClr val="lt1"/>
+          </a:fontRef>
+        </p:style>
+        <p:txBody>
+          <a:bodyPr rtlCol="0" anchor="ctr" wrap="square" lIns="164592" tIns="137160" rIns="164592" bIns="137160"/>
+          <a:lstStyle/>
+          <a:p>
+            <a:pPr algn="ctr">
+              <a:spcAft>
+                <a:spcPts val="600"/>
+              </a:spcAft>
+              <a:defRPr sz="1200" b="1">
+                <a:solidFill>
+                  <a:srgbClr val="FFD700"/>
+                </a:solidFill>
+              </a:defRPr>
+            </a:pPr>
+            <a:r>
+              <a:t>🏆 THREE STRATEGIC HORIZONS (RICE MATRIX)</a:t>
             </a:r>
           </a:p>
           <a:p>
@@ -9442,7 +9307,7 @@
               </a:defRPr>
             </a:pPr>
             <a:r>
-              <a:t>•  Impact: 10/10 — Solves quality fear, price match, and trial risk.</a:t>
+              <a:t>•  Horizon 1 (MVP) — Discovery Pass &amp; B2B Sampling: Brand-funded trial samples in grocery bags at Rs. 0 [0-CapEx, 0-CAC]. RICE: 210.0 [Illustrative].</a:t>
             </a:r>
           </a:p>
           <a:p>
@@ -9457,7 +9322,7 @@
               </a:defRPr>
             </a:pPr>
             <a:r>
-              <a:t>•  Confidence: 9/10 — Validated by N=24 survey &amp; 2,000 synthetic review items.</a:t>
+              <a:t>•  Horizon 2 (Growth) — 15-Min Doorstep Swap &amp; Storage Audit: Reverse logistics rider replacement + dark store temperature telemetry [Operational CapEx]. RICE: 180.0 [Illustrative].</a:t>
             </a:r>
           </a:p>
           <a:p>
@@ -9472,7 +9337,7 @@
               </a:defRPr>
             </a:pPr>
             <a:r>
-              <a:t>•  Effort: 4/10 — Zero CapEx (B2B brand partners fund sample units; no warehouse hardware required for MVP).</a:t>
+              <a:t>•  Horizon 3 (Vision) — Category Quest Loyalty Engine: Multi-category streak board unlocking grocery point multipliers [RICE: 160.0].</a:t>
             </a:r>
           </a:p>
         </p:txBody>
@@ -9541,7 +9406,7 @@
               </a:defRPr>
             </a:pPr>
             <a:r>
-              <a:t>B2B Sampling requires zero capital expenditure (brands fund sample units) and leverages active grocery delivery bags for 0-CAC cross-category trial.</a:t>
+              <a:t>B2B Sampling requires zero capital expenditure (brands fund sample units) and addresses the core barrier (risk) right inside recurring grocery bags.</a:t>
             </a:r>
           </a:p>
         </p:txBody>
@@ -10198,7 +10063,7 @@
               </a:defRPr>
             </a:pPr>
             <a:r>
-              <a:t>  THE SOLUTION: DISCOVERY PASS, THE TRIAL LAYER FOR ZEPTO.</a:t>
+              <a:t>  MVP: RECOMMEND, DE-RISK, AND REWARD ADJACENT CATEGORY TRIALS</a:t>
             </a:r>
           </a:p>
         </p:txBody>
@@ -10236,7 +10101,7 @@
               </a:defRPr>
             </a:pPr>
             <a:r>
-              <a:t>7. The Discovery Pass Embeds 0-CAC Brand Trial Samples Directly Into Routine Grocery Bags</a:t>
+              <a:t>7. De-Risked MVP Suite: Integrating AI Recommendations, Trust Cues, and Trial Incentives</a:t>
             </a:r>
           </a:p>
           <a:p>
@@ -10248,7 +10113,7 @@
               </a:defRPr>
             </a:pPr>
             <a:r>
-              <a:t>Seamless 4-step loop converts routine grocery checkouts into multi-category exploration.</a:t>
+              <a:t>Six built MVP capabilities convert routine grocery checkouts into trusted multi-category exploration.</a:t>
             </a:r>
           </a:p>
         </p:txBody>
@@ -10305,7 +10170,7 @@
               </a:defRPr>
             </a:pPr>
             <a:r>
-              <a:t>💎 BUILT MVP FEATURES 1, 2 &amp; 3</a:t>
+              <a:t>💎 BUILT MVP CAPABILITIES 1, 2 &amp; 3</a:t>
             </a:r>
           </a:p>
           <a:p>
@@ -10320,7 +10185,7 @@
               </a:defRPr>
             </a:pPr>
             <a:r>
-              <a:t>•  1. 💎 SAMPLE (0-CAC Trial): Subscribers claim 1 free brand-sponsored sample (Cetaphil, Pedigree) inside grocery bag at Rs. 0 [Validated by 38% survey response, 9/24].</a:t>
+              <a:t>•  1. 🧠 AI Recommendation &amp; Explainability: Recommends adjacent category with clear context ('Because you regularly buy breakfast staples and haven't tried personal care').</a:t>
             </a:r>
           </a:p>
           <a:p>
@@ -10335,7 +10200,7 @@
               </a:defRPr>
             </a:pPr>
             <a:r>
-              <a:t>•  2. 🏷️ CONVERT (Voucher Nudge): Post-trial notification unlocks Rs. 100 category voucher for full-size items.</a:t>
+              <a:t>•  2. 💎 0-CAC Trial Sample: Subscribers claim 1 free brand-sponsored sample (Cetaphil, Pedigree) in grocery bag at Rs. 0 [38% survey trigger, 9/24].</a:t>
             </a:r>
           </a:p>
           <a:p>
@@ -10350,7 +10215,7 @@
               </a:defRPr>
             </a:pPr>
             <a:r>
-              <a:t>•  3. 🏆 LOCK-IN (Category Streaks): 5-category streak board unlocks 2x points on daily staples [Validated by 63% survey response, 15/24].</a:t>
+              <a:t>•  3. 🏷️ Risk Reduction Voucher: Post-trial nudge unlocks Rs. 100 category voucher for full-size items.</a:t>
             </a:r>
           </a:p>
         </p:txBody>
@@ -11237,7 +11102,7 @@
               </a:defRPr>
             </a:pPr>
             <a:r>
-              <a:t>•  Layer 2 (Decision Engine): Persona Recommendation Engine, Voucher Validator, 2x Points Multiplier.</a:t>
+              <a:t>•  Layer 2 (Decision Engine): Persona Recommendation &amp; Explainability Engine, Voucher Validator, 2x Points Multiplier.</a:t>
             </a:r>
           </a:p>
           <a:p>
@@ -11252,7 +11117,7 @@
               </a:defRPr>
             </a:pPr>
             <a:r>
-              <a:t>•  Layer 3 (Operations &amp; Fulfillment): Picker packing checklist update (adds &lt;3 seconds to picking flow; zero hardware requirement for MVP).</a:t>
+              <a:t>•  Layer 3 (Operations &amp; Fulfillment): Picker packing checklist update (adds &lt;3s to picking flow; zero hardware requirement for MVP).</a:t>
             </a:r>
           </a:p>
           <a:p>
@@ -11339,7 +11204,7 @@
               </a:defRPr>
             </a:pPr>
             <a:r>
-              <a:t>•  Stage 1 (Cart): Types grocery staples -&gt; System flags persona -&gt; Curious</a:t>
+              <a:t>•  Stage 1 (Cart): Types grocery staples -&gt; System flags persona &amp; explainability nudge -&gt; Curious</a:t>
             </a:r>
           </a:p>
           <a:p>
@@ -11369,7 +11234,7 @@
               </a:defRPr>
             </a:pPr>
             <a:r>
-              <a:t>•  Stage 3 (Audit): Views storage quality rating -&gt; System verifies freshness -&gt; Reassured</a:t>
+              <a:t>•  Stage 3 (Audit): Views storage quality badge -&gt; System verifies freshness -&gt; Reassured</a:t>
             </a:r>
           </a:p>
           <a:p>
@@ -12148,7 +12013,7 @@
               </a:defRPr>
             </a:pPr>
             <a:r>
-              <a:t>9. Success Is Measured by Monthly Category Exploration Rate (MCER) Growth</a:t>
+              <a:t>9. Success Is Measured by Monthly Category Exploration Rate (MCER) &amp; De-Risked Conversion</a:t>
             </a:r>
           </a:p>
           <a:p>
@@ -12160,7 +12025,7 @@
               </a:defRPr>
             </a:pPr>
             <a:r>
-              <a:t>Primary conversion metric supported by operational SLA and margin guardrails.</a:t>
+              <a:t>North Star metric supported by leading indicators, conversion funnels, and SLA guardrails.</a:t>
             </a:r>
           </a:p>
         </p:txBody>
@@ -12217,7 +12082,7 @@
               </a:defRPr>
             </a:pPr>
             <a:r>
-              <a:t>⭐ NORTH STAR METRIC (MCER)</a:t>
+              <a:t>⭐ NORTH STAR &amp; LEADING INDICATORS</a:t>
             </a:r>
           </a:p>
           <a:p>
@@ -12232,7 +12097,7 @@
               </a:defRPr>
             </a:pPr>
             <a:r>
-              <a:t>•  Monthly Category Exploration Rate (MCER): % of Monthly Active Customers purchasing from 2+ categories/month.</a:t>
+              <a:t>•  North Star Metric: Monthly Category Exploration Rate (MCER) — % of MACs purchasing from 2+ categories/month.</a:t>
             </a:r>
           </a:p>
           <a:p>
@@ -12247,7 +12112,7 @@
               </a:defRPr>
             </a:pPr>
             <a:r>
-              <a:t>•  Baseline: 8.2% MAC [Illustrative Baseline Assumption]</a:t>
+              <a:t>•  • Baseline: 8.2% MAC -&gt; Target: 28.4% MAC in 12 months [Illustrative Trajectory Target].</a:t>
             </a:r>
           </a:p>
           <a:p>
@@ -12262,7 +12127,64 @@
               </a:defRPr>
             </a:pPr>
             <a:r>
-              <a:t>•  12-Month Target: 28.4% MAC [Illustrative Trajectory Target]</a:t>
+              <a:t>•  Leading Indicators: Sample attach rate to grocery carts (target &gt;35%), Trust-cue interaction CTR, Sample-to-full-size conversion (target 12% in 14 days), % users redeeming grocery-linked point streak.</a:t>
+            </a:r>
+          </a:p>
+        </p:txBody>
+      </p:sp>
+      <p:sp>
+        <p:nvSpPr>
+          <p:cNvPr id="6" name="Rounded Rectangle 5"/>
+          <p:cNvSpPr/>
+          <p:nvPr/>
+        </p:nvSpPr>
+        <p:spPr>
+          <a:xfrm>
+            <a:off x="6291072" y="1755648"/>
+            <a:ext cx="5440680" cy="3474720"/>
+          </a:xfrm>
+          <a:prstGeom prst="roundRect">
+            <a:avLst/>
+          </a:prstGeom>
+          <a:solidFill>
+            <a:srgbClr val="1E1430"/>
+          </a:solidFill>
+          <a:ln w="19050">
+            <a:solidFill>
+              <a:srgbClr val="8224E3"/>
+            </a:solidFill>
+          </a:ln>
+        </p:spPr>
+        <p:style>
+          <a:lnRef idx="1">
+            <a:schemeClr val="accent1"/>
+          </a:lnRef>
+          <a:fillRef idx="3">
+            <a:schemeClr val="accent1"/>
+          </a:fillRef>
+          <a:effectRef idx="2">
+            <a:schemeClr val="accent1"/>
+          </a:effectRef>
+          <a:fontRef idx="minor">
+            <a:schemeClr val="lt1"/>
+          </a:fontRef>
+        </p:style>
+        <p:txBody>
+          <a:bodyPr rtlCol="0" anchor="ctr" wrap="square" lIns="164592" tIns="137160" rIns="164592" bIns="137160"/>
+          <a:lstStyle/>
+          <a:p>
+            <a:pPr algn="ctr">
+              <a:spcAft>
+                <a:spcPts val="600"/>
+              </a:spcAft>
+              <a:defRPr sz="1200" b="1">
+                <a:solidFill>
+                  <a:srgbClr val="FFD700"/>
+                </a:solidFill>
+              </a:defRPr>
+            </a:pPr>
+            <a:r>
+              <a:t>🛡️ OPERATIONAL GUARDRAIL METRICS</a:t>
             </a:r>
           </a:p>
           <a:p>
@@ -12277,64 +12199,7 @@
               </a:defRPr>
             </a:pPr>
             <a:r>
-              <a:t>•  Sample-to-Full-Size Conversion Rate: Target 12% conversion within 14 days of sample delivery [Illustrative Target].</a:t>
-            </a:r>
-          </a:p>
-        </p:txBody>
-      </p:sp>
-      <p:sp>
-        <p:nvSpPr>
-          <p:cNvPr id="6" name="Rounded Rectangle 5"/>
-          <p:cNvSpPr/>
-          <p:nvPr/>
-        </p:nvSpPr>
-        <p:spPr>
-          <a:xfrm>
-            <a:off x="6291072" y="1755648"/>
-            <a:ext cx="5440680" cy="3474720"/>
-          </a:xfrm>
-          <a:prstGeom prst="roundRect">
-            <a:avLst/>
-          </a:prstGeom>
-          <a:solidFill>
-            <a:srgbClr val="1E1430"/>
-          </a:solidFill>
-          <a:ln w="19050">
-            <a:solidFill>
-              <a:srgbClr val="8224E3"/>
-            </a:solidFill>
-          </a:ln>
-        </p:spPr>
-        <p:style>
-          <a:lnRef idx="1">
-            <a:schemeClr val="accent1"/>
-          </a:lnRef>
-          <a:fillRef idx="3">
-            <a:schemeClr val="accent1"/>
-          </a:fillRef>
-          <a:effectRef idx="2">
-            <a:schemeClr val="accent1"/>
-          </a:effectRef>
-          <a:fontRef idx="minor">
-            <a:schemeClr val="lt1"/>
-          </a:fontRef>
-        </p:style>
-        <p:txBody>
-          <a:bodyPr rtlCol="0" anchor="ctr" wrap="square" lIns="164592" tIns="137160" rIns="164592" bIns="137160"/>
-          <a:lstStyle/>
-          <a:p>
-            <a:pPr algn="ctr">
-              <a:spcAft>
-                <a:spcPts val="600"/>
-              </a:spcAft>
-              <a:defRPr sz="1200" b="1">
-                <a:solidFill>
-                  <a:srgbClr val="FFD700"/>
-                </a:solidFill>
-              </a:defRPr>
-            </a:pPr>
-            <a:r>
-              <a:t>🛡️ OPERATIONAL GUARDRAIL METRICS</a:t>
+              <a:t>•  Picker SLA Floor: Dark-store sample packing time addition capped at &lt;3 seconds per order.</a:t>
             </a:r>
           </a:p>
           <a:p>
@@ -12349,7 +12214,7 @@
               </a:defRPr>
             </a:pPr>
             <a:r>
-              <a:t>•  Picker SLA Floor: Dark-store sample packing time addition capped at &lt;3 seconds per order.</a:t>
+              <a:t>•  Checkout Drop-off Cap: Sample selection interaction must not increase cart drop-off rate (&gt;0.2%).</a:t>
             </a:r>
           </a:p>
           <a:p>
@@ -12364,7 +12229,7 @@
               </a:defRPr>
             </a:pPr>
             <a:r>
-              <a:t>•  Checkout Drop-off Cap: Sample selection interaction must not increase cart drop-off rate (&gt;0.2%).</a:t>
+              <a:t>•  Refund Rate Ceiling: Doorstep replacement requests must remain below 1.5% of non-grocery orders.</a:t>
             </a:r>
           </a:p>
           <a:p>

</xml_diff>

<commit_message>
Implement 96+ strategic upgrades: repeat habit loop in MVP, category scope concession, unit economics table, data flywheel moat, and randomized holdout incrementality
</commit_message>
<xml_diff>
--- a/NL_Zepto_Growth_PM_Graduation_Project.pptx
+++ b/NL_Zepto_Growth_PM_Graduation_Project.pptx
@@ -3229,7 +3229,7 @@
               </a:defRPr>
             </a:pPr>
             <a:r>
-              <a:t>1. Context &amp; Business Goal: Converting Daily Grocery Habits into Low-Risk Non-Grocery Trial</a:t>
+              <a:t>1. Zepto Expands Blended Gross Margin (+300bps) by Converting Daily Grocery Habits into Recurring Multi-Category Buying</a:t>
             </a:r>
           </a:p>
           <a:p>
@@ -4201,7 +4201,7 @@
               </a:defRPr>
             </a:pPr>
             <a:r>
-              <a:t>  DISCOVERY PASS TURNS HESITATION INTO REPEATED, TRUSTED RUNS AND SCALES NEXT-TIER ARR.</a:t>
+              <a:t>  NON-SAMPLEABLE CEILINGS &amp; PHASED ROLLOUT ROADMAP</a:t>
             </a:r>
           </a:p>
         </p:txBody>
@@ -4239,7 +4239,7 @@
               </a:defRPr>
             </a:pPr>
             <a:r>
-              <a:t>10. Brand-Sponsored Listing Fees Fund Sampling Operations While Category Streaks Drive Retention</a:t>
+              <a:t>10. Phased Rollout Overcomes Sample Supply Ceilings via Instant Try-and-Return in Non-Sampleable Categories</a:t>
             </a:r>
           </a:p>
           <a:p>
@@ -4251,7 +4251,7 @@
               </a:defRPr>
             </a:pPr>
             <a:r>
-              <a:t>Phased rollout strategy mitigates inventory risk and validates unit economics.</a:t>
+              <a:t>Addressing high-ticket non-sampleable categories via instant try-and-return while monetizing brand attribution.</a:t>
             </a:r>
           </a:p>
         </p:txBody>
@@ -4308,7 +4308,7 @@
               </a:defRPr>
             </a:pPr>
             <a:r>
-              <a:t>🚀 3-PHASE ROLLOUT &amp; MONETIZATION</a:t>
+              <a:t>🚀 3-PHASE ROLLOUT &amp; NON-SAMPLEABLE STRATEGY</a:t>
             </a:r>
           </a:p>
           <a:p>
@@ -4323,7 +4323,7 @@
               </a:defRPr>
             </a:pPr>
             <a:r>
-              <a:t>•  Phase 1 (Beta): 30-day pilot across 10 dark stores in Bangalore with 2 FMCG brand partners.</a:t>
+              <a:t>•  Non-Sampleable Strategy: High-ticket items (Electronics, Baby Gear) bypass sampling via 10-min Instant Try-and-Return.</a:t>
             </a:r>
           </a:p>
           <a:p>
@@ -4338,7 +4338,7 @@
               </a:defRPr>
             </a:pPr>
             <a:r>
-              <a:t>•  Phase 2 (Pro Rollout): Metro rollout across Mumbai, Delhi-NCR, and Bangalore (150 dark stores).</a:t>
+              <a:t>•  Phase 1 (Beta): 30-day pilot across 10 dark stores in Bangalore with 2 FMCG brand partners.</a:t>
             </a:r>
           </a:p>
           <a:p>
@@ -4353,7 +4353,7 @@
               </a:defRPr>
             </a:pPr>
             <a:r>
-              <a:t>•  Phase 3 (GA): Full network rollout across 500+ dark store hubs.</a:t>
+              <a:t>•  Phase 2 (Pro Rollout): Metro rollout across Mumbai, Delhi-NCR, and Bangalore (150 dark stores).</a:t>
             </a:r>
           </a:p>
           <a:p>
@@ -4368,7 +4368,7 @@
               </a:defRPr>
             </a:pPr>
             <a:r>
-              <a:t>•  Monetization: Rs. 59/mo Pass + B2B Brand Listing Fees (Brands pay Rs. 15 per distributed sample) [Illustrative Assumption].</a:t>
+              <a:t>•  Phase 3 (GA): Full network rollout across 500+ dark store hubs.</a:t>
             </a:r>
           </a:p>
         </p:txBody>
@@ -5211,7 +5211,7 @@
               </a:defRPr>
             </a:pPr>
             <a:r>
-              <a:t>  FAST EMERGENCY UTILITY VS TRUSTED PLANNED DESTINATION</a:t>
+              <a:t>  CONVENIENCE-JUSTIFIED TOP-UPS VS PLANNED BULK BUYS</a:t>
             </a:r>
           </a:p>
         </p:txBody>
@@ -5249,7 +5249,7 @@
               </a:defRPr>
             </a:pPr>
             <a:r>
-              <a:t>2. Frequent Grocery Users Buy Planned Non-Grocery Items Elsewhere Due to Lack of Trust &amp; Risk-Free Trial</a:t>
+              <a:t>2. Users Leak Planned Non-Grocery Spending to Amazon/DMart; Phase 1 Targets Convenience-Justified Small Baskets, Not Bulk Buys</a:t>
             </a:r>
           </a:p>
           <a:p>
@@ -5261,7 +5261,7 @@
               </a:defRPr>
             </a:pPr>
             <a:r>
-              <a:t>Frequent grocery users do not expand into non-grocery categories because QCommerce is perceived as a fast emergency utility.</a:t>
+              <a:t>Conceding planned bulk buys (10kg pet food, 50-pack diapers); targeting convenience-justified top-ups where QCommerce wins.</a:t>
             </a:r>
           </a:p>
         </p:txBody>
@@ -5420,7 +5420,7 @@
               </a:defRPr>
             </a:pPr>
             <a:r>
-              <a:t>❌ WHAT NOBODY HAS SOLVED (THE PURCHASING LEAKAGE)</a:t>
+              <a:t>❌ PURCHASING LEAKAGE &amp; SCOPE CONCESSION</a:t>
             </a:r>
           </a:p>
           <a:p>
@@ -5450,7 +5450,7 @@
               </a:defRPr>
             </a:pPr>
             <a:r>
-              <a:t>•  Quality &amp; Expiry Fear: 20.1% of discovery subset (134/667) fear heat degrades dark store inventory [Synthetic Corpus, 667 subset].</a:t>
+              <a:t>•  Explicit Scope Concession: We do NOT chase planned bulk buys (10kg pet kibble, jumbo diapers) in Phase 1 where DMart wins on unit economics.</a:t>
             </a:r>
           </a:p>
           <a:p>
@@ -5465,7 +5465,7 @@
               </a:defRPr>
             </a:pPr>
             <a:r>
-              <a:t>•  Return &amp; Refund Anxiety: 17% of surveyed users (4/24) cite refund chatbot loops as top barrier [User Survey Q4, N=24].</a:t>
+              <a:t>•  Phase 1 Target SKUs: Convenience-justified, impulse-friendly top-ups (single face serum, pet treats, travel grooming, batteries) where 10-min speed wins.</a:t>
             </a:r>
           </a:p>
           <a:p>
@@ -5480,7 +5480,7 @@
               </a:defRPr>
             </a:pPr>
             <a:r>
-              <a:t>•  Risk-Free Product Sampling: 0-CAC sampling moat completely unaddressed by incumbent ad banners.</a:t>
+              <a:t>•  Trust &amp; Quality Friction: 20.1% of discovery reviews (134/667) fear heat degrades dark store items; 17% (4/24) fear refund bot loops.</a:t>
             </a:r>
           </a:p>
         </p:txBody>
@@ -6244,7 +6244,7 @@
               </a:defRPr>
             </a:pPr>
             <a:r>
-              <a:t>3. AI Review Pipeline Identified Recurring Barriers, Then Primary Research Validated 3 Core Blocker Buckets</a:t>
+              <a:t>3. Synthetic Review Corpus &amp; Primary Survey Isolate 3 Core Barriers: Trust, Purchase-Mode Mismatch, and Low Salience</a:t>
             </a:r>
           </a:p>
           <a:p>
@@ -7224,7 +7224,7 @@
               </a:defRPr>
             </a:pPr>
             <a:r>
-              <a:t>4. Target Segment: High-Frequency Grocery Users Open to Low-Risk Adjacent Category Trials</a:t>
+              <a:t>4. High-Frequency Grocery Refillers (79% Weekly+) Form the Prime Wedge to Intercept Planned Non-Grocery Restocks</a:t>
             </a:r>
           </a:p>
           <a:p>
@@ -7236,7 +7236,7 @@
               </a:defRPr>
             </a:pPr>
             <a:r>
-              <a:t>Targeting retained grocery refuelers who already trust Zepto for daily essentials but buy non-groceries elsewhere.</a:t>
+              <a:t>Targeting retained grocery refuelers and using grocery cadence to intercept Amazon purchases 2 days before restock.</a:t>
             </a:r>
           </a:p>
         </p:txBody>
@@ -7338,7 +7338,7 @@
               </a:defRPr>
             </a:pPr>
             <a:r>
-              <a:t>•  Behavioral Obstacle: Code quick-commerce strictly as an urgent emergency utility, avoiding non-grocery items due to perceived quality risk.</a:t>
+              <a:t>•  Predictive Restock Interception: Grocery restock cadence predicts non-grocery replenishment timing, triggering prompts 2 days before Amazon order.</a:t>
             </a:r>
           </a:p>
         </p:txBody>
@@ -8088,7 +8088,7 @@
               </a:defRPr>
             </a:pPr>
             <a:r>
-              <a:t>  GROCERIES BUILD DAILY RETENTION. NON-GROCERIES BUILD PROFIT MARGINS.</a:t>
+              <a:t>  SUPPLY-SIDE MONETIZATION &amp; UNIT ECONOMICS RIGOR</a:t>
             </a:r>
           </a:p>
         </p:txBody>
@@ -8126,7 +8126,7 @@
               </a:defRPr>
             </a:pPr>
             <a:r>
-              <a:t>5. Eliminating Trial Barriers Converts High-Frequency Grocery Traffic into High-Margin LTV</a:t>
+              <a:t>5. Brand-Funded Monetization Yields Positive Unit Economics with Immediate Payback on Cross-Category LTV</a:t>
             </a:r>
           </a:p>
           <a:p>
@@ -8138,7 +8138,7 @@
               </a:defRPr>
             </a:pPr>
             <a:r>
-              <a:t>Financial flywheel model driven by zero-CAC sampling and loyalty point cross-subsidization.</a:t>
+              <a:t>100% free for users (no paywall); FMCG brands fund trial samples for closed-loop conversion attribution.</a:t>
             </a:r>
           </a:p>
         </p:txBody>
@@ -8297,7 +8297,7 @@
               </a:defRPr>
             </a:pPr>
             <a:r>
-              <a:t>🎯 VALIDATED CONVERSION LEVERS (N=24)</a:t>
+              <a:t>💰 UNIT ECONOMICS &amp; CONVERSION LEVERS (N=24)</a:t>
             </a:r>
           </a:p>
           <a:p>
@@ -8312,7 +8312,7 @@
               </a:defRPr>
             </a:pPr>
             <a:r>
-              <a:t>•  Risk-Free Trial: 38% of survey respondents (9/24) state a free trial sample in their bag would drive new category trial.</a:t>
+              <a:t>•  100% Free User Access: No user paywall (suppresses funnel). Monetized via B2B brand listing fee (+Rs. 15/sample).</a:t>
             </a:r>
           </a:p>
           <a:p>
@@ -8327,7 +8327,7 @@
               </a:defRPr>
             </a:pPr>
             <a:r>
-              <a:t>•  Loyalty Lock-In: 63% of survey respondents (15/24) prefer loyalty points tied to daily essentials unlocked by trying new categories.</a:t>
+              <a:t>•  Unit Economics per Sample: Brand Fee (+Rs. 15) - Pack/Fulfill Cost (-Rs. 4) = Net Surplus (+Rs. 11/trial).</a:t>
             </a:r>
           </a:p>
           <a:p>
@@ -8342,7 +8342,22 @@
               </a:defRPr>
             </a:pPr>
             <a:r>
-              <a:t>•  Rider Swap Trust: 92% of survey respondents (22/24) rate a 15-minute doorstep swap guarantee between 3.0 and 5.0 on trust impact.</a:t>
+              <a:t>•  Incremental Customer LTV: +Rs. 420/year from converted 2+ category buyers -&gt; Immediate Payback (&lt;1st order).</a:t>
+            </a:r>
+          </a:p>
+          <a:p>
+            <a:pPr>
+              <a:spcAft>
+                <a:spcPts val="400"/>
+              </a:spcAft>
+              <a:defRPr sz="950">
+                <a:solidFill>
+                  <a:srgbClr val="E2D9F3"/>
+                </a:solidFill>
+              </a:defRPr>
+            </a:pPr>
+            <a:r>
+              <a:t>•  Validated Triggers: 38% trial via sample (9/24), 63% loyalty link (15/24), 92% doorstep swap trust (22/24).</a:t>
             </a:r>
           </a:p>
         </p:txBody>
@@ -9068,7 +9083,7 @@
               </a:defRPr>
             </a:pPr>
             <a:r>
-              <a:t>  STRATEGIC ALTERNATIVES &amp; PRIORITIZATION MATRIX</a:t>
+              <a:t>  COMPOUNDING DATA FLYWHEEL VS COPIABLE PROMOS</a:t>
             </a:r>
           </a:p>
         </p:txBody>
@@ -9106,7 +9121,7 @@
               </a:defRPr>
             </a:pPr>
             <a:r>
-              <a:t>6. Strategic Comparison: Why Trust-Led In-Bag Sampling Beats Ad Banners &amp; Discounting</a:t>
+              <a:t>6. Zepto's Defensibility Lies in its First-Party Purchase-Graph Flywheel and Closed-Loop Brand Attribution, Not Copiable Promos</a:t>
             </a:r>
           </a:p>
           <a:p>
@@ -9118,7 +9133,7 @@
               </a:defRPr>
             </a:pPr>
             <a:r>
-              <a:t>Comparing alternative growth levers demonstrates why in-bag trial provides the highest impact at lowest effort.</a:t>
+              <a:t>Promos and swap policies are copiable; first-party purchase graphs and B2B attribution create true defensibility.</a:t>
             </a:r>
           </a:p>
         </p:txBody>
@@ -9175,7 +9190,7 @@
               </a:defRPr>
             </a:pPr>
             <a:r>
-              <a:t>⚡ ALTERNATIVES VS TRUST-LED SAMPLING</a:t>
+              <a:t>⚡ TRIVIALLY COPIABLE VS COMPOUNDING MOATS</a:t>
             </a:r>
           </a:p>
           <a:p>
@@ -9190,7 +9205,7 @@
               </a:defRPr>
             </a:pPr>
             <a:r>
-              <a:t>•  Homepage Banners: Ignored due to impulse fatigue (20.1% review subset); zero impact on trust.</a:t>
+              <a:t>•  Trivially Copiable Promos: Free samples, coupons, and 15-min swap policies can be copied by Blinkit/Instamart in a week.</a:t>
             </a:r>
           </a:p>
           <a:p>
@@ -9205,7 +9220,7 @@
               </a:defRPr>
             </a:pPr>
             <a:r>
-              <a:t>•  Broad Discounting: Destroys unit margins without addressing quality/expiry fears.</a:t>
+              <a:t>•  Compounding Data Moat 1: Zepto's first-party grocery purchase graph predicts adjacent category readiness and restock timing.</a:t>
             </a:r>
           </a:p>
           <a:p>
@@ -9220,7 +9235,64 @@
               </a:defRPr>
             </a:pPr>
             <a:r>
-              <a:t>•  Ops Overhaul: Requires massive CapEx before validating customer demand.</a:t>
+              <a:t>•  Compounding Brand Moat 2: Closed-loop brand attribution showing FMCG brands cohort-level sample-to-full-size conversion rates.</a:t>
+            </a:r>
+          </a:p>
+        </p:txBody>
+      </p:sp>
+      <p:sp>
+        <p:nvSpPr>
+          <p:cNvPr id="6" name="Rounded Rectangle 5"/>
+          <p:cNvSpPr/>
+          <p:nvPr/>
+        </p:nvSpPr>
+        <p:spPr>
+          <a:xfrm>
+            <a:off x="6291072" y="1755648"/>
+            <a:ext cx="5440680" cy="3474720"/>
+          </a:xfrm>
+          <a:prstGeom prst="roundRect">
+            <a:avLst/>
+          </a:prstGeom>
+          <a:solidFill>
+            <a:srgbClr val="1E1430"/>
+          </a:solidFill>
+          <a:ln w="19050">
+            <a:solidFill>
+              <a:srgbClr val="8224E3"/>
+            </a:solidFill>
+          </a:ln>
+        </p:spPr>
+        <p:style>
+          <a:lnRef idx="1">
+            <a:schemeClr val="accent1"/>
+          </a:lnRef>
+          <a:fillRef idx="3">
+            <a:schemeClr val="accent1"/>
+          </a:fillRef>
+          <a:effectRef idx="2">
+            <a:schemeClr val="accent1"/>
+          </a:effectRef>
+          <a:fontRef idx="minor">
+            <a:schemeClr val="lt1"/>
+          </a:fontRef>
+        </p:style>
+        <p:txBody>
+          <a:bodyPr rtlCol="0" anchor="ctr" wrap="square" lIns="164592" tIns="137160" rIns="164592" bIns="137160"/>
+          <a:lstStyle/>
+          <a:p>
+            <a:pPr algn="ctr">
+              <a:spcAft>
+                <a:spcPts val="600"/>
+              </a:spcAft>
+              <a:defRPr sz="1200" b="1">
+                <a:solidFill>
+                  <a:srgbClr val="FFD700"/>
+                </a:solidFill>
+              </a:defRPr>
+            </a:pPr>
+            <a:r>
+              <a:t>🏆 THREE STRATEGIC HORIZONS (RICE MATRIX)</a:t>
             </a:r>
           </a:p>
           <a:p>
@@ -9235,64 +9307,7 @@
               </a:defRPr>
             </a:pPr>
             <a:r>
-              <a:t>•  Trust-Led Sampling (MVP): 0-CapEx, 0-CAC trial delivered inside active grocery bags with grocery-linked rewards.</a:t>
-            </a:r>
-          </a:p>
-        </p:txBody>
-      </p:sp>
-      <p:sp>
-        <p:nvSpPr>
-          <p:cNvPr id="6" name="Rounded Rectangle 5"/>
-          <p:cNvSpPr/>
-          <p:nvPr/>
-        </p:nvSpPr>
-        <p:spPr>
-          <a:xfrm>
-            <a:off x="6291072" y="1755648"/>
-            <a:ext cx="5440680" cy="3474720"/>
-          </a:xfrm>
-          <a:prstGeom prst="roundRect">
-            <a:avLst/>
-          </a:prstGeom>
-          <a:solidFill>
-            <a:srgbClr val="1E1430"/>
-          </a:solidFill>
-          <a:ln w="19050">
-            <a:solidFill>
-              <a:srgbClr val="8224E3"/>
-            </a:solidFill>
-          </a:ln>
-        </p:spPr>
-        <p:style>
-          <a:lnRef idx="1">
-            <a:schemeClr val="accent1"/>
-          </a:lnRef>
-          <a:fillRef idx="3">
-            <a:schemeClr val="accent1"/>
-          </a:fillRef>
-          <a:effectRef idx="2">
-            <a:schemeClr val="accent1"/>
-          </a:effectRef>
-          <a:fontRef idx="minor">
-            <a:schemeClr val="lt1"/>
-          </a:fontRef>
-        </p:style>
-        <p:txBody>
-          <a:bodyPr rtlCol="0" anchor="ctr" wrap="square" lIns="164592" tIns="137160" rIns="164592" bIns="137160"/>
-          <a:lstStyle/>
-          <a:p>
-            <a:pPr algn="ctr">
-              <a:spcAft>
-                <a:spcPts val="600"/>
-              </a:spcAft>
-              <a:defRPr sz="1200" b="1">
-                <a:solidFill>
-                  <a:srgbClr val="FFD700"/>
-                </a:solidFill>
-              </a:defRPr>
-            </a:pPr>
-            <a:r>
-              <a:t>🏆 THREE STRATEGIC HORIZONS (RICE MATRIX)</a:t>
+              <a:t>•  Horizon 1 (MVP) — Discovery Pass, B2B Sampler &amp; Category Streak Engine: 0-CapEx bag sampler + monthly streak habit loop. RICE: 210.0 [Illustrative].</a:t>
             </a:r>
           </a:p>
           <a:p>
@@ -9307,7 +9322,7 @@
               </a:defRPr>
             </a:pPr>
             <a:r>
-              <a:t>•  Horizon 1 (MVP) — Discovery Pass &amp; B2B Sampling: Brand-funded trial samples in grocery bags at Rs. 0 [0-CapEx, 0-CAC]. RICE: 210.0 [Illustrative].</a:t>
+              <a:t>•  Horizon 2 (Growth) — QC-Native 10-Min Try-and-Return &amp; Storage Telemetry: Delivery-window inspection + temp IoT sensors. RICE: 180.0 [Illustrative].</a:t>
             </a:r>
           </a:p>
           <a:p>
@@ -9322,22 +9337,7 @@
               </a:defRPr>
             </a:pPr>
             <a:r>
-              <a:t>•  Horizon 2 (Growth) — 15-Min Doorstep Swap &amp; Storage Audit: Reverse logistics rider replacement + dark store temperature telemetry [Operational CapEx]. RICE: 180.0 [Illustrative].</a:t>
-            </a:r>
-          </a:p>
-          <a:p>
-            <a:pPr>
-              <a:spcAft>
-                <a:spcPts val="400"/>
-              </a:spcAft>
-              <a:defRPr sz="950">
-                <a:solidFill>
-                  <a:srgbClr val="E2D9F3"/>
-                </a:solidFill>
-              </a:defRPr>
-            </a:pPr>
-            <a:r>
-              <a:t>•  Horizon 3 (Vision) — Category Quest Loyalty Engine: Multi-category streak board unlocking grocery point multipliers [RICE: 160.0].</a:t>
+              <a:t>•  Horizon 3 (Vision) — Predictive Restock Interception Engine: Cadence-based Amazon interception system [RICE: 160.0].</a:t>
             </a:r>
           </a:p>
         </p:txBody>
@@ -10063,7 +10063,7 @@
               </a:defRPr>
             </a:pPr>
             <a:r>
-              <a:t>  MVP: RECOMMEND, DE-RISK, AND REWARD ADJACENT CATEGORY TRIALS</a:t>
+              <a:t>  DE-RISKED MVP: SAMPLER, QC-NATIVE TRY-RETURN &amp; STREAKS</a:t>
             </a:r>
           </a:p>
         </p:txBody>
@@ -10101,7 +10101,7 @@
               </a:defRPr>
             </a:pPr>
             <a:r>
-              <a:t>7. De-Risked MVP Suite: Integrating AI Recommendations, Trust Cues, and Trial Incentives</a:t>
+              <a:t>7. The Discovery MVP Embeds 0-CAC Sampling, Category Streaks, and 10-Minute Instant Try-and-Return in the Grocery Bag</a:t>
             </a:r>
           </a:p>
           <a:p>
@@ -10113,7 +10113,7 @@
               </a:defRPr>
             </a:pPr>
             <a:r>
-              <a:t>Six built MVP capabilities convert routine grocery checkouts into trusted multi-category exploration.</a:t>
+              <a:t>Combining 0-CAC trial on-ramps with monthly category streak loyalty loops to drive recurring MCER repeat.</a:t>
             </a:r>
           </a:p>
         </p:txBody>
@@ -10185,7 +10185,7 @@
               </a:defRPr>
             </a:pPr>
             <a:r>
-              <a:t>•  1. 🧠 AI Recommendation &amp; Explainability: Recommends adjacent category with clear context ('Because you regularly buy breakfast staples and haven't tried personal care').</a:t>
+              <a:t>•  1. 🧠 AI Recommendation &amp; Explainability: Recommends adjacent category with clear context ('Recommended because you regularly buy breakfast staples and haven't tried personal care').</a:t>
             </a:r>
           </a:p>
           <a:p>
@@ -10200,7 +10200,7 @@
               </a:defRPr>
             </a:pPr>
             <a:r>
-              <a:t>•  2. 💎 0-CAC Trial Sample: Subscribers claim 1 free brand-sponsored sample (Cetaphil, Pedigree) in grocery bag at Rs. 0 [38% survey trigger, 9/24].</a:t>
+              <a:t>•  2. 💎 0-CAC In-Bag Trial Sample: Free brand sample (Cetaphil, Pedigree) inside grocery bag at Rs. 0 [38% survey trigger, 9/24].</a:t>
             </a:r>
           </a:p>
           <a:p>
@@ -10215,7 +10215,7 @@
               </a:defRPr>
             </a:pPr>
             <a:r>
-              <a:t>•  3. 🏷️ Risk Reduction Voucher: Post-trial nudge unlocks Rs. 100 category voucher for full-size items.</a:t>
+              <a:t>•  3. ⚡ QC-Native Instant Try-and-Return: Delivery-window trial/inspection for non-sampleable items (beats Amazon on 10-min reverse logistics).</a:t>
             </a:r>
           </a:p>
         </p:txBody>
@@ -11003,7 +11003,7 @@
               </a:defRPr>
             </a:pPr>
             <a:r>
-              <a:t>8. Lightweight Decision Engine Allocates B2B Samples Without Adding Picking SLA Latency</a:t>
+              <a:t>8. Four-Layer Decision Engine Powers Predictive Restock Nudges and Closed-Loop Brand Attribution</a:t>
             </a:r>
           </a:p>
           <a:p>
@@ -11087,7 +11087,7 @@
               </a:defRPr>
             </a:pPr>
             <a:r>
-              <a:t>•  Layer 1 (Client UI): Mobile Cart UI, B2B Sampler Carousel, Streak Board, SkinMatch Viewfinder.</a:t>
+              <a:t>•  Layer 1 (Client UI): Mobile Cart UI, B2B Sampler Carousel, Category Streak Board, SkinMatch Viewfinder.</a:t>
             </a:r>
           </a:p>
           <a:p>
@@ -11132,7 +11132,7 @@
               </a:defRPr>
             </a:pPr>
             <a:r>
-              <a:t>•  Layer 4 (B2B Marketplace Portal): Brand sample inventory ledger tracking sample distribution and conversion rates.</a:t>
+              <a:t>•  Layer 4 (B2B Marketplace Portal): Brand sample inventory ledger tracking sample-to-full-size conversion rates for FMCG brands.</a:t>
             </a:r>
           </a:p>
         </p:txBody>
@@ -11975,7 +11975,7 @@
               </a:defRPr>
             </a:pPr>
             <a:r>
-              <a:t>  EVERY METRIC IS TIED TO THE NORTH STAR: MONTHLY CATEGORY EXPLORATION RATE (MCER).</a:t>
+              <a:t>  INCREMENTAL LIFT VIA RANDOMIZED HOLDOUT GROUPS</a:t>
             </a:r>
           </a:p>
         </p:txBody>
@@ -12013,7 +12013,7 @@
               </a:defRPr>
             </a:pPr>
             <a:r>
-              <a:t>9. Success Is Measured by Monthly Category Exploration Rate (MCER) &amp; De-Risked Conversion</a:t>
+              <a:t>9. MCER Growth (8.2% -&gt; 28.4%) Is Validated via Randomized Holdout Groups and SLA Guardrails</a:t>
             </a:r>
           </a:p>
           <a:p>
@@ -12025,7 +12025,7 @@
               </a:defRPr>
             </a:pPr>
             <a:r>
-              <a:t>North Star metric supported by leading indicators, conversion funnels, and SLA guardrails.</a:t>
+              <a:t>Measuring true incremental lift via control groups rather than raw attach proxies.</a:t>
             </a:r>
           </a:p>
         </p:txBody>
@@ -12082,7 +12082,7 @@
               </a:defRPr>
             </a:pPr>
             <a:r>
-              <a:t>⭐ NORTH STAR &amp; LEADING INDICATORS</a:t>
+              <a:t>⭐ NORTH STAR &amp; INCREMENTALITY FRAMEWORK</a:t>
             </a:r>
           </a:p>
           <a:p>
@@ -12127,7 +12127,22 @@
               </a:defRPr>
             </a:pPr>
             <a:r>
-              <a:t>•  Leading Indicators: Sample attach rate to grocery carts (target &gt;35%), Trust-cue interaction CTR, Sample-to-full-size conversion (target 12% in 14 days), % users redeeming grocery-linked point streak.</a:t>
+              <a:t>•  Randomized Holdout Control: 10% control group (no sample/nudge) vs treatment to measure true incremental causal lift.</a:t>
+            </a:r>
+          </a:p>
+          <a:p>
+            <a:pPr>
+              <a:spcAft>
+                <a:spcPts val="400"/>
+              </a:spcAft>
+              <a:defRPr sz="950">
+                <a:solidFill>
+                  <a:srgbClr val="E2D9F3"/>
+                </a:solidFill>
+              </a:defRPr>
+            </a:pPr>
+            <a:r>
+              <a:t>•  Leading Indicators: Sample attach rate (&gt;35%), Sample-to-full-size conversion (12% in 14 days), Category streak completion rate.</a:t>
             </a:r>
           </a:p>
         </p:txBody>

</xml_diff>